<commit_message>
Fix Slide 1 framing: use the research question from Zonation_Reanalysis.pptx
Reframed Slide 1 around the project's actual research question (verbatim source:
archive/legacy_reports/Zonation_Reanalysis.pptx slides 2-3), not the de-zonation claim:
- Left box = the formal research question: published claim "Hepatocytes lose their
  zonation" -> does hepatocyte zonation degrade across MASLD, and is that linked to the
  hepatocyte->cholangiocyte transdifferentiation Paper 1 reported?
- Right box = the clause-by-clause answer: no detectable biopsy-stage degradation; the
  healthy->end-stage drop is the tissue-acquisition axis; transdifferentiation link can't
  be established (biliary markers rise only in explants).
- Speaker notes updated to the question-led framing.

Co-Authored-By: Claude Opus 4.8 <noreply@anthropic.com>
</commit_message>
<xml_diff>
--- a/reports/deck/MASLD_zonation_reanalysis_8min.pptx
+++ b/reports/deck/MASLD_zonation_reanalysis_8min.pptx
@@ -522,7 +522,7 @@
           <a:p>
             <a:r>
               <a:rPr lang="en-US" dirty="0"/>
-              <a:t>Open: the paper's claim is exciting — as chronic liver disease progresses, hepatocytes lose their zonation, and the most de-zonated ones move toward a biliary/cholangiocyte identity (the headline plasticity finding). Note these are two distinct axes: de-zonation = losing your position along the lobule (still a hepatocyte); transdifferentiation = losing your cell-type identity. We asked whether the single-nucleus EXPRESSION evidence for progressive de-zonation survives once acquisition differences are controlled. Answer up front: in matched needle biopsies, transcriptional zonation is preserved.</a:t>
+              <a:t>Frame it as the project's research question (from the Zonation_Reanalysis framing): the published claim is 'hepatocytes lose their zonation,' and our formal question was whether we can measure how much hepatocyte zonation degrades across MASLD and whether that is linked to the transdifferentiation Paper 1 reported. Answer, clause by clause: the relative ruler is the wrong instrument; there is no detectable biopsy-stage degradation (F1→cirrhotic F4); the healthy→end-stage drop is the tissue-acquisition axis, not disease; and the transdifferentiation link can't be established because biliary markers stay ~0 across biopsy disease and rise only in explants — the same confound.</a:t>
             </a:r>
             <a:endParaRPr lang="en-US" dirty="0"/>
           </a:p>
@@ -2762,8 +2762,8 @@
         </p:nvSpPr>
         <p:spPr>
           <a:xfrm>
-            <a:off x="822960" y="2852928"/>
-            <a:ext cx="4663440" cy="1325880"/>
+            <a:off x="822960" y="2834640"/>
+            <a:ext cx="4663440" cy="1371600"/>
           </a:xfrm>
           <a:prstGeom prst="rect">
             <a:avLst/>
@@ -2779,26 +2779,26 @@
               <a:buNone/>
             </a:pPr>
             <a:r>
-              <a:rPr lang="en-US" sz="1600" b="1" dirty="0">
+              <a:rPr lang="en-US" sz="1450" b="1" dirty="0">
                 <a:solidFill>
                   <a:srgbClr val="FCA5A5"/>
                 </a:solidFill>
               </a:rPr>
-              <a:t>Published claim — Gribben et al.
+              <a:t>The research question (Gribben et al., Nature 2024)
 </a:t>
             </a:r>
             <a:pPr algn="l" indent="0" marL="0">
               <a:buNone/>
             </a:pPr>
             <a:r>
-              <a:rPr lang="en-US" sz="1350" dirty="0">
+              <a:rPr lang="en-US" sz="1300" dirty="0">
                 <a:solidFill>
                   <a:srgbClr val="FECACA"/>
                 </a:solidFill>
               </a:rPr>
-              <a:t>“Hepatocytes lose their zonation” as MASLD progresses, and de-zonated hepatocytes transdifferentiate toward cholangiocytes (epithelial plasticity).</a:t>
-            </a:r>
-            <a:endParaRPr lang="en-US" sz="1600" dirty="0"/>
+              <a:t>Published claim: “Hepatocytes lose their zonation.”  Does hepatocyte zonation degrade across MASLD — and is that degradation linked to the hepatocyte→cholangiocyte transdifferentiation Paper 1 reported?</a:t>
+            </a:r>
+            <a:endParaRPr lang="en-US" sz="1450" dirty="0"/>
           </a:p>
         </p:txBody>
       </p:sp>
@@ -2857,8 +2857,8 @@
         </p:nvSpPr>
         <p:spPr>
           <a:xfrm>
-            <a:off x="6675120" y="2852928"/>
-            <a:ext cx="4663440" cy="1325880"/>
+            <a:off x="6675120" y="2834640"/>
+            <a:ext cx="4663440" cy="1371600"/>
           </a:xfrm>
           <a:prstGeom prst="rect">
             <a:avLst/>
@@ -2874,26 +2874,26 @@
               <a:buNone/>
             </a:pPr>
             <a:r>
-              <a:rPr lang="en-US" sz="1600" b="1" dirty="0">
+              <a:rPr lang="en-US" sz="1450" b="1" dirty="0">
                 <a:solidFill>
                   <a:srgbClr val="5EEAD4"/>
                 </a:solidFill>
               </a:rPr>
-              <a:t>This re-analysis — matched biopsies
+              <a:t>Our answer — matched biopsies
 </a:t>
             </a:r>
             <a:pPr algn="l" indent="0" marL="0">
               <a:buNone/>
             </a:pPr>
             <a:r>
-              <a:rPr lang="en-US" sz="1350" dirty="0">
+              <a:rPr lang="en-US" sz="1300" dirty="0">
                 <a:solidFill>
                   <a:srgbClr val="99F6E4"/>
                 </a:solidFill>
               </a:rPr>
-              <a:t>transcriptional zonation preserved; the reported de-zonation tracks tissue-source confounding; the biliary signal is most consistent with composition / ambient RNA.</a:t>
-            </a:r>
-            <a:endParaRPr lang="en-US" sz="1600" dirty="0"/>
+              <a:t>No detectable biopsy-stage degradation (F1→cirrhotic F4); the “healthy→end-stage” drop is the tissue-acquisition axis; the transdifferentiation link can’t be established (biliary markers rise only in explants).</a:t>
+            </a:r>
+            <a:endParaRPr lang="en-US" sz="1450" dirty="0"/>
           </a:p>
         </p:txBody>
       </p:sp>
@@ -2905,8 +2905,8 @@
         </p:nvSpPr>
         <p:spPr>
           <a:xfrm>
-            <a:off x="640080" y="4617720"/>
-            <a:ext cx="10881360" cy="1554480"/>
+            <a:off x="640080" y="4709160"/>
+            <a:ext cx="10881360" cy="1371600"/>
           </a:xfrm>
           <a:prstGeom prst="rect">
             <a:avLst/>
@@ -2920,21 +2920,21 @@
           <a:p>
             <a:pPr algn="l" indent="0" marL="0">
               <a:spcAft>
-                <a:spcPts val="800"/>
+                <a:spcPts val="1000"/>
               </a:spcAft>
               <a:buNone/>
             </a:pPr>
             <a:r>
               <a:rPr lang="en-US" sz="1800" b="1" dirty="0">
                 <a:solidFill>
-                  <a:srgbClr val="93C5FD"/>
-                </a:solidFill>
-              </a:rPr>
-              <a:t>Question  </a:t>
+                  <a:srgbClr val="5EEAD4"/>
+                </a:solidFill>
+              </a:rPr>
+              <a:t>In one line  </a:t>
             </a:r>
             <a:pPr algn="l" indent="0" marL="0">
               <a:spcAft>
-                <a:spcPts val="800"/>
+                <a:spcPts val="1000"/>
               </a:spcAft>
               <a:buNone/>
             </a:pPr>
@@ -2944,7 +2944,7 @@
                   <a:srgbClr val="E2E8F0"/>
                 </a:solidFill>
               </a:rPr>
-              <a:t>is the snRNA-seq evidence for progressive de-zonation robust?
+              <a:t>the apparent de-zonation is a tissue-acquisition artifact; matched biopsies stay transcriptionally zonated.
 </a:t>
             </a:r>
             <a:endParaRPr lang="en-US" sz="1800" dirty="0"/>
@@ -2952,53 +2952,21 @@
           <a:p>
             <a:pPr algn="l" indent="0" marL="0">
               <a:spcAft>
-                <a:spcPts val="800"/>
+                <a:spcPts val="1000"/>
               </a:spcAft>
               <a:buNone/>
             </a:pPr>
             <a:r>
               <a:rPr lang="en-US" sz="1800" b="1" dirty="0">
                 <a:solidFill>
-                  <a:srgbClr val="5EEAD4"/>
-                </a:solidFill>
-              </a:rPr>
-              <a:t>Answer  </a:t>
+                  <a:srgbClr val="CBD5E1"/>
+                </a:solidFill>
+              </a:rPr>
+              <a:t>Scope  </a:t>
             </a:r>
             <a:pPr algn="l" indent="0" marL="0">
               <a:spcAft>
-                <a:spcPts val="800"/>
-              </a:spcAft>
-              <a:buNone/>
-            </a:pPr>
-            <a:r>
-              <a:rPr lang="en-US" sz="1800" dirty="0">
-                <a:solidFill>
-                  <a:srgbClr val="E2E8F0"/>
-                </a:solidFill>
-              </a:rPr>
-              <a:t>not across matched biopsy F1–F4 tissue.
-</a:t>
-            </a:r>
-            <a:endParaRPr lang="en-US" sz="1800" dirty="0"/>
-          </a:p>
-          <a:p>
-            <a:pPr algn="l" indent="0" marL="0">
-              <a:spcAft>
-                <a:spcPts val="800"/>
-              </a:spcAft>
-              <a:buNone/>
-            </a:pPr>
-            <a:r>
-              <a:rPr lang="en-US" sz="1800" b="1" dirty="0">
-                <a:solidFill>
-                  <a:srgbClr val="CBD5E1"/>
-                </a:solidFill>
-              </a:rPr>
-              <a:t>Scope  </a:t>
-            </a:r>
-            <a:pPr algn="l" indent="0" marL="0">
-              <a:spcAft>
-                <a:spcPts val="800"/>
+                <a:spcPts val="1000"/>
               </a:spcAft>
               <a:buNone/>
             </a:pPr>

</xml_diff>